<commit_message>
feat(slides): embed publication figures into decks and add chart interpretations to defense guides
</commit_message>
<xml_diff>
--- a/Evaluación de Inyección SQL Espacial en PostGIS.pptx
+++ b/Evaluación de Inyección SQL Espacial en PostGIS.pptx
@@ -12502,7 +12502,7 @@
         <p:spPr>
           <a:xfrm>
             <a:off x="4394150" y="1600200"/>
-            <a:ext cx="3403500" cy="3478800"/>
+            <a:ext cx="3403500" cy="3749039"/>
           </a:xfrm>
           <a:prstGeom prst="roundRect">
             <a:avLst>
@@ -13273,8 +13273,8 @@
         </p:nvSpPr>
         <p:spPr>
           <a:xfrm>
-            <a:off x="4632275" y="2838450"/>
-            <a:ext cx="3022500" cy="701700"/>
+            <a:off x="4632275" y="2788920"/>
+            <a:ext cx="3022500" cy="411480"/>
           </a:xfrm>
           <a:prstGeom prst="rect">
             <a:avLst/>
@@ -13301,6 +13301,7 @@
                 <a:spcPts val="0"/>
               </a:spcAft>
               <a:buNone/>
+              <a:defRPr sz="1100"/>
             </a:pPr>
             <a:r>
               <a:rPr b="0" i="0" lang="en-US" sz="1200" u="none" cap="none" strike="noStrike">
@@ -14212,6 +14213,30 @@
           </a:p>
         </p:txBody>
       </p:sp>
+      <p:pic>
+        <p:nvPicPr>
+          <p:cNvPr id="153" name="Picture 152" descr="fig3_spatial_dos_complexity.png"/>
+          <p:cNvPicPr>
+            <a:picLocks noChangeAspect="1"/>
+          </p:cNvPicPr>
+          <p:nvPr/>
+        </p:nvPicPr>
+        <p:blipFill>
+          <a:blip r:embed="rId3"/>
+          <a:stretch>
+            <a:fillRect/>
+          </a:stretch>
+        </p:blipFill>
+        <p:spPr>
+          <a:xfrm>
+            <a:off x="4526280" y="3291840"/>
+            <a:ext cx="3154680" cy="1822704"/>
+          </a:xfrm>
+          <a:prstGeom prst="rect">
+            <a:avLst/>
+          </a:prstGeom>
+        </p:spPr>
+      </p:pic>
     </p:spTree>
   </p:cSld>
   <p:clrMapOvr>
@@ -14302,8 +14327,8 @@
         </p:nvSpPr>
         <p:spPr>
           <a:xfrm>
-            <a:off x="685800" y="1461112"/>
-            <a:ext cx="10668000" cy="950700"/>
+            <a:off x="685800" y="1280160"/>
+            <a:ext cx="10668000" cy="685800"/>
           </a:xfrm>
           <a:prstGeom prst="roundRect">
             <a:avLst>
@@ -14361,8 +14386,8 @@
         </p:nvSpPr>
         <p:spPr>
           <a:xfrm>
-            <a:off x="685800" y="2583127"/>
-            <a:ext cx="10668000" cy="1177200"/>
+            <a:off x="685800" y="2057400"/>
+            <a:ext cx="10668000" cy="685800"/>
           </a:xfrm>
           <a:prstGeom prst="roundRect">
             <a:avLst>
@@ -14420,8 +14445,8 @@
         </p:nvSpPr>
         <p:spPr>
           <a:xfrm>
-            <a:off x="685800" y="3931808"/>
-            <a:ext cx="10668000" cy="1177200"/>
+            <a:off x="685800" y="2834640"/>
+            <a:ext cx="10668000" cy="685800"/>
           </a:xfrm>
           <a:prstGeom prst="roundRect">
             <a:avLst>
@@ -14479,8 +14504,8 @@
         </p:nvSpPr>
         <p:spPr>
           <a:xfrm>
-            <a:off x="962100" y="1638133"/>
-            <a:ext cx="419100" cy="419100"/>
+            <a:off x="962100" y="1371600"/>
+            <a:ext cx="329184" cy="329184"/>
           </a:xfrm>
           <a:prstGeom prst="roundRect">
             <a:avLst>
@@ -14532,8 +14557,8 @@
         </p:nvSpPr>
         <p:spPr>
           <a:xfrm>
-            <a:off x="962025" y="2856592"/>
-            <a:ext cx="419100" cy="419100"/>
+            <a:off x="962025" y="2148840"/>
+            <a:ext cx="329184" cy="329184"/>
           </a:xfrm>
           <a:prstGeom prst="roundRect">
             <a:avLst>
@@ -14585,8 +14610,8 @@
         </p:nvSpPr>
         <p:spPr>
           <a:xfrm>
-            <a:off x="962100" y="4197623"/>
-            <a:ext cx="419100" cy="419100"/>
+            <a:off x="962100" y="2926080"/>
+            <a:ext cx="329184" cy="329184"/>
           </a:xfrm>
           <a:prstGeom prst="roundRect">
             <a:avLst>
@@ -14638,7 +14663,7 @@
         </p:nvSpPr>
         <p:spPr>
           <a:xfrm>
-            <a:off x="819150" y="1726770"/>
+            <a:off x="819150" y="1399032"/>
             <a:ext cx="705000" cy="207900"/>
           </a:xfrm>
           <a:prstGeom prst="rect">
@@ -14688,7 +14713,7 @@
         </p:nvSpPr>
         <p:spPr>
           <a:xfrm>
-            <a:off x="819150" y="2962192"/>
+            <a:off x="819150" y="2176272"/>
             <a:ext cx="705000" cy="207900"/>
           </a:xfrm>
           <a:prstGeom prst="rect">
@@ -14738,7 +14763,7 @@
         </p:nvSpPr>
         <p:spPr>
           <a:xfrm>
-            <a:off x="819150" y="4310873"/>
+            <a:off x="819150" y="2953512"/>
             <a:ext cx="705000" cy="207900"/>
           </a:xfrm>
           <a:prstGeom prst="rect">
@@ -14788,7 +14813,7 @@
         </p:nvSpPr>
         <p:spPr>
           <a:xfrm>
-            <a:off x="1647825" y="1680187"/>
+            <a:off x="1647825" y="1325880"/>
             <a:ext cx="10467900" cy="231000"/>
           </a:xfrm>
           <a:prstGeom prst="rect">
@@ -14838,7 +14863,7 @@
         </p:nvSpPr>
         <p:spPr>
           <a:xfrm>
-            <a:off x="1647825" y="1965937"/>
+            <a:off x="1647825" y="1572768"/>
             <a:ext cx="10467900" cy="196200"/>
           </a:xfrm>
           <a:prstGeom prst="rect">
@@ -14866,6 +14891,7 @@
                 <a:spcPts val="0"/>
               </a:spcAft>
               <a:buNone/>
+              <a:defRPr sz="1100"/>
             </a:pPr>
             <a:r>
               <a:rPr b="0" i="0" lang="en-US" sz="1275" u="none" cap="none" strike="noStrike">
@@ -14891,7 +14917,7 @@
         </p:nvSpPr>
         <p:spPr>
           <a:xfrm>
-            <a:off x="1647825" y="2802202"/>
+            <a:off x="1647825" y="2103120"/>
             <a:ext cx="10467900" cy="231000"/>
           </a:xfrm>
           <a:prstGeom prst="rect">
@@ -14941,7 +14967,7 @@
         </p:nvSpPr>
         <p:spPr>
           <a:xfrm>
-            <a:off x="1647825" y="3087952"/>
+            <a:off x="1647825" y="2350008"/>
             <a:ext cx="9525000" cy="471000"/>
           </a:xfrm>
           <a:prstGeom prst="rect">
@@ -14969,6 +14995,7 @@
                 <a:spcPts val="0"/>
               </a:spcAft>
               <a:buNone/>
+              <a:defRPr sz="1100"/>
             </a:pPr>
             <a:r>
               <a:rPr b="0" i="0" lang="en-US" sz="1275" u="none" cap="none" strike="noStrike">
@@ -14994,7 +15021,7 @@
         </p:nvSpPr>
         <p:spPr>
           <a:xfrm>
-            <a:off x="1647825" y="4150883"/>
+            <a:off x="1647825" y="2880360"/>
             <a:ext cx="10467900" cy="231000"/>
           </a:xfrm>
           <a:prstGeom prst="rect">
@@ -15044,7 +15071,7 @@
         </p:nvSpPr>
         <p:spPr>
           <a:xfrm>
-            <a:off x="1647825" y="4436633"/>
+            <a:off x="1647825" y="3127248"/>
             <a:ext cx="9525000" cy="471000"/>
           </a:xfrm>
           <a:prstGeom prst="rect">
@@ -15072,6 +15099,7 @@
                 <a:spcPts val="0"/>
               </a:spcAft>
               <a:buNone/>
+              <a:defRPr sz="1100"/>
             </a:pPr>
             <a:r>
               <a:rPr b="0" i="0" lang="en-US" sz="1275" u="none" cap="none" strike="noStrike">
@@ -15089,6 +15117,30 @@
           </a:p>
         </p:txBody>
       </p:sp>
+      <p:pic>
+        <p:nvPicPr>
+          <p:cNvPr id="173" name="Picture 172" descr="fig1_defense_pipeline.png"/>
+          <p:cNvPicPr>
+            <a:picLocks noChangeAspect="1"/>
+          </p:cNvPicPr>
+          <p:nvPr/>
+        </p:nvPicPr>
+        <p:blipFill>
+          <a:blip r:embed="rId3"/>
+          <a:stretch>
+            <a:fillRect/>
+          </a:stretch>
+        </p:blipFill>
+        <p:spPr>
+          <a:xfrm>
+            <a:off x="2432304" y="3657600"/>
+            <a:ext cx="7315200" cy="2560320"/>
+          </a:xfrm>
+          <a:prstGeom prst="rect">
+            <a:avLst/>
+          </a:prstGeom>
+        </p:spPr>
+      </p:pic>
     </p:spTree>
   </p:cSld>
   <p:clrMapOvr>
@@ -15179,8 +15231,8 @@
         </p:nvSpPr>
         <p:spPr>
           <a:xfrm>
-            <a:off x="762000" y="3009900"/>
-            <a:ext cx="10668000" cy="1696500"/>
+            <a:off x="762000" y="2331720"/>
+            <a:ext cx="10668000" cy="1234440"/>
           </a:xfrm>
           <a:prstGeom prst="roundRect">
             <a:avLst>
@@ -15238,8 +15290,8 @@
         </p:nvSpPr>
         <p:spPr>
           <a:xfrm>
-            <a:off x="762000" y="1504950"/>
-            <a:ext cx="3403500" cy="1257300"/>
+            <a:off x="762000" y="1234440"/>
+            <a:ext cx="3403500" cy="1005840"/>
           </a:xfrm>
           <a:prstGeom prst="roundRect">
             <a:avLst>
@@ -15297,8 +15349,8 @@
         </p:nvSpPr>
         <p:spPr>
           <a:xfrm>
-            <a:off x="4394150" y="1504950"/>
-            <a:ext cx="3403500" cy="1257300"/>
+            <a:off x="4394150" y="1234440"/>
+            <a:ext cx="3403500" cy="1005840"/>
           </a:xfrm>
           <a:prstGeom prst="roundRect">
             <a:avLst>
@@ -15356,8 +15408,8 @@
         </p:nvSpPr>
         <p:spPr>
           <a:xfrm>
-            <a:off x="8026300" y="1504950"/>
-            <a:ext cx="3403500" cy="1257300"/>
+            <a:off x="8026300" y="1234440"/>
+            <a:ext cx="3403500" cy="1005840"/>
           </a:xfrm>
           <a:prstGeom prst="roundRect">
             <a:avLst>
@@ -15414,7 +15466,7 @@
           <p:nvPr/>
         </p:nvGraphicFramePr>
         <p:xfrm>
-          <a:off x="962025" y="3190875"/>
+          <a:off x="962025" y="2423160"/>
           <a:ext cx="3000000" cy="3000000"/>
         </p:xfrm>
         <a:graphic>
@@ -15444,6 +15496,7 @@
                           <a:spcPts val="0"/>
                         </a:spcAft>
                         <a:buNone/>
+                        <a:defRPr sz="1100"/>
                       </a:pPr>
                       <a:r>
                         <a:rPr b="1" i="0" lang="en-US" sz="1050" u="none" cap="none" strike="noStrike">
@@ -15523,6 +15576,7 @@
                           <a:spcPts val="0"/>
                         </a:spcAft>
                         <a:buNone/>
+                        <a:defRPr sz="1100"/>
                       </a:pPr>
                       <a:r>
                         <a:rPr b="1" i="0" lang="en-US" sz="1050" u="none" cap="none" strike="noStrike">
@@ -15602,6 +15656,7 @@
                           <a:spcPts val="0"/>
                         </a:spcAft>
                         <a:buNone/>
+                        <a:defRPr sz="1100"/>
                       </a:pPr>
                       <a:r>
                         <a:rPr b="1" i="0" lang="en-US" sz="1050" u="none" cap="none" strike="noStrike">
@@ -15681,6 +15736,7 @@
                           <a:spcPts val="0"/>
                         </a:spcAft>
                         <a:buNone/>
+                        <a:defRPr sz="1100"/>
                       </a:pPr>
                       <a:r>
                         <a:rPr b="1" i="0" lang="en-US" sz="1050" u="none" cap="none" strike="noStrike">
@@ -15762,6 +15818,7 @@
                           <a:spcPts val="0"/>
                         </a:spcAft>
                         <a:buNone/>
+                        <a:defRPr sz="1100"/>
                       </a:pPr>
                       <a:r>
                         <a:rPr b="1" i="0" lang="en-US" sz="1200" u="none" cap="none" strike="noStrike">
@@ -15841,6 +15898,7 @@
                           <a:spcPts val="0"/>
                         </a:spcAft>
                         <a:buNone/>
+                        <a:defRPr sz="1100"/>
                       </a:pPr>
                       <a:r>
                         <a:rPr b="1" i="0" lang="en-US" sz="1200" u="none" cap="none" strike="noStrike">
@@ -15920,6 +15978,7 @@
                           <a:spcPts val="0"/>
                         </a:spcAft>
                         <a:buNone/>
+                        <a:defRPr sz="1100"/>
                       </a:pPr>
                       <a:r>
                         <a:rPr b="0" i="0" lang="en-US" sz="1200" u="none" cap="none" strike="noStrike">
@@ -15999,6 +16058,7 @@
                           <a:spcPts val="0"/>
                         </a:spcAft>
                         <a:buNone/>
+                        <a:defRPr sz="1100"/>
                       </a:pPr>
                       <a:r>
                         <a:rPr b="0" i="0" lang="en-US" sz="1200" u="none" cap="none" strike="noStrike">
@@ -16080,6 +16140,7 @@
                           <a:spcPts val="0"/>
                         </a:spcAft>
                         <a:buNone/>
+                        <a:defRPr sz="1100"/>
                       </a:pPr>
                       <a:r>
                         <a:rPr b="1" i="0" lang="en-US" sz="1200" u="none" cap="none" strike="noStrike">
@@ -16159,6 +16220,7 @@
                           <a:spcPts val="0"/>
                         </a:spcAft>
                         <a:buNone/>
+                        <a:defRPr sz="1100"/>
                       </a:pPr>
                       <a:r>
                         <a:rPr b="1" i="0" lang="en-US" sz="1200" u="none" cap="none" strike="noStrike">
@@ -16238,6 +16300,7 @@
                           <a:spcPts val="0"/>
                         </a:spcAft>
                         <a:buNone/>
+                        <a:defRPr sz="1100"/>
                       </a:pPr>
                       <a:r>
                         <a:rPr b="1" i="0" lang="en-US" sz="1200" u="none" cap="none" strike="noStrike">
@@ -16317,6 +16380,7 @@
                           <a:spcPts val="0"/>
                         </a:spcAft>
                         <a:buNone/>
+                        <a:defRPr sz="1100"/>
                       </a:pPr>
                       <a:r>
                         <a:rPr b="1" i="0" lang="en-US" sz="1200" u="none" cap="none" strike="noStrike">
@@ -16396,7 +16460,7 @@
         </p:nvSpPr>
         <p:spPr>
           <a:xfrm>
-            <a:off x="1000125" y="1704975"/>
+            <a:off x="1000125" y="1325880"/>
             <a:ext cx="3659100" cy="161700"/>
           </a:xfrm>
           <a:prstGeom prst="rect">
@@ -16446,7 +16510,7 @@
         </p:nvSpPr>
         <p:spPr>
           <a:xfrm>
-            <a:off x="1000125" y="1924050"/>
+            <a:off x="1000125" y="1536192"/>
             <a:ext cx="3659100" cy="484800"/>
           </a:xfrm>
           <a:prstGeom prst="rect">
@@ -16499,7 +16563,7 @@
         </p:nvSpPr>
         <p:spPr>
           <a:xfrm>
-            <a:off x="1000125" y="2381250"/>
+            <a:off x="1000125" y="1965960"/>
             <a:ext cx="3659100" cy="173100"/>
           </a:xfrm>
           <a:prstGeom prst="rect">
@@ -16524,6 +16588,7 @@
                 <a:spcPts val="0"/>
               </a:spcAft>
               <a:buNone/>
+              <a:defRPr sz="1000"/>
             </a:pPr>
             <a:r>
               <a:rPr b="0" i="0" lang="en-US" sz="1125" u="none" cap="none" strike="noStrike">
@@ -16549,7 +16614,7 @@
         </p:nvSpPr>
         <p:spPr>
           <a:xfrm>
-            <a:off x="4632275" y="1704975"/>
+            <a:off x="4632275" y="1325880"/>
             <a:ext cx="3659100" cy="161700"/>
           </a:xfrm>
           <a:prstGeom prst="rect">
@@ -16599,7 +16664,7 @@
         </p:nvSpPr>
         <p:spPr>
           <a:xfrm>
-            <a:off x="4632275" y="1924050"/>
+            <a:off x="4632275" y="1536192"/>
             <a:ext cx="3659100" cy="484800"/>
           </a:xfrm>
           <a:prstGeom prst="rect">
@@ -16652,7 +16717,7 @@
         </p:nvSpPr>
         <p:spPr>
           <a:xfrm>
-            <a:off x="4632275" y="2381250"/>
+            <a:off x="4632275" y="1965960"/>
             <a:ext cx="3659100" cy="173100"/>
           </a:xfrm>
           <a:prstGeom prst="rect">
@@ -16677,6 +16742,7 @@
                 <a:spcPts val="0"/>
               </a:spcAft>
               <a:buNone/>
+              <a:defRPr sz="1000"/>
             </a:pPr>
             <a:r>
               <a:rPr b="0" i="0" lang="en-US" sz="1125" u="none" cap="none" strike="noStrike">
@@ -16702,7 +16768,7 @@
         </p:nvSpPr>
         <p:spPr>
           <a:xfrm>
-            <a:off x="8264425" y="1704975"/>
+            <a:off x="8264425" y="1325880"/>
             <a:ext cx="3659100" cy="161700"/>
           </a:xfrm>
           <a:prstGeom prst="rect">
@@ -16752,7 +16818,7 @@
         </p:nvSpPr>
         <p:spPr>
           <a:xfrm>
-            <a:off x="8264425" y="1924050"/>
+            <a:off x="8264425" y="1536192"/>
             <a:ext cx="3659100" cy="484800"/>
           </a:xfrm>
           <a:prstGeom prst="rect">
@@ -16805,7 +16871,7 @@
         </p:nvSpPr>
         <p:spPr>
           <a:xfrm>
-            <a:off x="8264425" y="2381250"/>
+            <a:off x="8264425" y="1965960"/>
             <a:ext cx="3659100" cy="173100"/>
           </a:xfrm>
           <a:prstGeom prst="rect">
@@ -16830,6 +16896,7 @@
                 <a:spcPts val="0"/>
               </a:spcAft>
               <a:buNone/>
+              <a:defRPr sz="1000"/>
             </a:pPr>
             <a:r>
               <a:rPr b="0" i="0" lang="en-US" sz="1125" u="none" cap="none" strike="noStrike">
@@ -16847,6 +16914,30 @@
           </a:p>
         </p:txBody>
       </p:sp>
+      <p:pic>
+        <p:nvPicPr>
+          <p:cNvPr id="192" name="Picture 191" descr="fig2_concurrency_latency.png"/>
+          <p:cNvPicPr>
+            <a:picLocks noChangeAspect="1"/>
+          </p:cNvPicPr>
+          <p:nvPr/>
+        </p:nvPicPr>
+        <p:blipFill>
+          <a:blip r:embed="rId3"/>
+          <a:stretch>
+            <a:fillRect/>
+          </a:stretch>
+        </p:blipFill>
+        <p:spPr>
+          <a:xfrm>
+            <a:off x="2432304" y="3703320"/>
+            <a:ext cx="7315200" cy="2813538"/>
+          </a:xfrm>
+          <a:prstGeom prst="rect">
+            <a:avLst/>
+          </a:prstGeom>
+        </p:spPr>
+      </p:pic>
     </p:spTree>
   </p:cSld>
   <p:clrMapOvr>

</xml_diff>